<commit_message>
stats on original data
</commit_message>
<xml_diff>
--- a/Data Exploration CA Template 2026.pptx
+++ b/Data Exploration CA Template 2026.pptx
@@ -292,7 +292,7 @@
   <pc:docChgLst>
     <pc:chgData name="A00043106 Amelia Stronska" userId="26b13220-5c28-497f-8887-6e4027d3be59" providerId="ADAL" clId="{431F7DB1-8E1F-4FC3-8BE5-1CB4D3E05321}"/>
     <pc:docChg chg="undo custSel addSld delSld modSld sldOrd">
-      <pc:chgData name="A00043106 Amelia Stronska" userId="26b13220-5c28-497f-8887-6e4027d3be59" providerId="ADAL" clId="{431F7DB1-8E1F-4FC3-8BE5-1CB4D3E05321}" dt="2026-03-26T17:15:54.559" v="1266" actId="2696"/>
+      <pc:chgData name="A00043106 Amelia Stronska" userId="26b13220-5c28-497f-8887-6e4027d3be59" providerId="ADAL" clId="{431F7DB1-8E1F-4FC3-8BE5-1CB4D3E05321}" dt="2026-03-26T18:02:25.578" v="1267" actId="14734"/>
       <pc:docMkLst>
         <pc:docMk/>
       </pc:docMkLst>
@@ -405,13 +405,13 @@
         </pc:graphicFrameChg>
       </pc:sldChg>
       <pc:sldChg chg="modSp add mod ord">
-        <pc:chgData name="A00043106 Amelia Stronska" userId="26b13220-5c28-497f-8887-6e4027d3be59" providerId="ADAL" clId="{431F7DB1-8E1F-4FC3-8BE5-1CB4D3E05321}" dt="2026-03-26T17:15:26.299" v="1262" actId="14734"/>
+        <pc:chgData name="A00043106 Amelia Stronska" userId="26b13220-5c28-497f-8887-6e4027d3be59" providerId="ADAL" clId="{431F7DB1-8E1F-4FC3-8BE5-1CB4D3E05321}" dt="2026-03-26T18:02:25.578" v="1267" actId="14734"/>
         <pc:sldMkLst>
           <pc:docMk/>
           <pc:sldMk cId="4132635650" sldId="299"/>
         </pc:sldMkLst>
         <pc:graphicFrameChg chg="mod modGraphic">
-          <ac:chgData name="A00043106 Amelia Stronska" userId="26b13220-5c28-497f-8887-6e4027d3be59" providerId="ADAL" clId="{431F7DB1-8E1F-4FC3-8BE5-1CB4D3E05321}" dt="2026-03-26T17:15:26.299" v="1262" actId="14734"/>
+          <ac:chgData name="A00043106 Amelia Stronska" userId="26b13220-5c28-497f-8887-6e4027d3be59" providerId="ADAL" clId="{431F7DB1-8E1F-4FC3-8BE5-1CB4D3E05321}" dt="2026-03-26T18:02:25.578" v="1267" actId="14734"/>
           <ac:graphicFrameMkLst>
             <pc:docMk/>
             <pc:sldMk cId="4132635650" sldId="299"/>
@@ -10313,7 +10313,7 @@
                     <a:bodyPr/>
                     <a:lstStyle/>
                     <a:p>
-                      <a:endParaRPr lang="en-IE"/>
+                      <a:endParaRPr lang="en-IE" dirty="0"/>
                     </a:p>
                   </a:txBody>
                   <a:tcPr/>
@@ -10889,14 +10889,14 @@
           <p:nvPr>
             <p:extLst>
               <p:ext uri="{D42A27DB-BD31-4B8C-83A1-F6EECF244321}">
-                <p14:modId xmlns:p14="http://schemas.microsoft.com/office/powerpoint/2010/main" val="3474093184"/>
+                <p14:modId xmlns:p14="http://schemas.microsoft.com/office/powerpoint/2010/main" val="2133017505"/>
               </p:ext>
             </p:extLst>
           </p:nvPr>
         </p:nvGraphicFramePr>
         <p:xfrm>
-          <a:off x="187779" y="1152475"/>
-          <a:ext cx="8768441" cy="3864655"/>
+          <a:off x="179614" y="1152475"/>
+          <a:ext cx="8776606" cy="3864655"/>
         </p:xfrm>
         <a:graphic>
           <a:graphicData uri="http://schemas.openxmlformats.org/drawingml/2006/table">
@@ -10905,7 +10905,7 @@
                 <a:tableStyleId>{7DF18680-E054-41AD-8BC1-D1AEF772440D}</a:tableStyleId>
               </a:tblPr>
               <a:tblGrid>
-                <a:gridCol w="938892">
+                <a:gridCol w="947057">
                   <a:extLst>
                     <a:ext uri="{9D8B030D-6E8A-4147-A177-3AD203B41FA5}">
                       <a16:colId xmlns:a16="http://schemas.microsoft.com/office/drawing/2014/main" val="2275553917"/>
@@ -11192,7 +11192,7 @@
                     <a:bodyPr/>
                     <a:lstStyle/>
                     <a:p>
-                      <a:endParaRPr lang="en-IE"/>
+                      <a:endParaRPr lang="en-IE" dirty="0"/>
                     </a:p>
                   </a:txBody>
                   <a:tcPr/>

</xml_diff>

<commit_message>
problems summary in excel
</commit_message>
<xml_diff>
--- a/Data Exploration CA Template 2026.pptx
+++ b/Data Exploration CA Template 2026.pptx
@@ -5,7 +5,7 @@
     <p:sldMasterId id="2147483659" r:id="rId1"/>
   </p:sldMasterIdLst>
   <p:notesMasterIdLst>
-    <p:notesMasterId r:id="rId22"/>
+    <p:notesMasterId r:id="rId24"/>
   </p:notesMasterIdLst>
   <p:sldIdLst>
     <p:sldId id="256" r:id="rId2"/>
@@ -20,14 +20,16 @@
     <p:sldId id="290" r:id="rId11"/>
     <p:sldId id="291" r:id="rId12"/>
     <p:sldId id="286" r:id="rId13"/>
-    <p:sldId id="266" r:id="rId14"/>
-    <p:sldId id="268" r:id="rId15"/>
-    <p:sldId id="269" r:id="rId16"/>
-    <p:sldId id="292" r:id="rId17"/>
-    <p:sldId id="293" r:id="rId18"/>
-    <p:sldId id="277" r:id="rId19"/>
-    <p:sldId id="278" r:id="rId20"/>
-    <p:sldId id="279" r:id="rId21"/>
+    <p:sldId id="300" r:id="rId14"/>
+    <p:sldId id="301" r:id="rId15"/>
+    <p:sldId id="266" r:id="rId16"/>
+    <p:sldId id="268" r:id="rId17"/>
+    <p:sldId id="269" r:id="rId18"/>
+    <p:sldId id="292" r:id="rId19"/>
+    <p:sldId id="293" r:id="rId20"/>
+    <p:sldId id="277" r:id="rId21"/>
+    <p:sldId id="278" r:id="rId22"/>
+    <p:sldId id="279" r:id="rId23"/>
   </p:sldIdLst>
   <p:sldSz cx="9144000" cy="5143500" type="screen16x9"/>
   <p:notesSz cx="6858000" cy="9144000"/>
@@ -282,7 +284,7 @@
 <file path=ppt/revisionInfo.xml><?xml version="1.0" encoding="utf-8"?>
 <p1510:revInfo xmlns:a="http://schemas.openxmlformats.org/drawingml/2006/main" xmlns:r="http://schemas.openxmlformats.org/officeDocument/2006/relationships" xmlns:p1510="http://schemas.microsoft.com/office/powerpoint/2015/10/main">
   <p1510:revLst>
-    <p1510:client id="{7479231F-5FE0-4255-B4A2-82B1AD35D662}" v="7" dt="2026-03-26T17:14:49.301"/>
+    <p1510:client id="{7479231F-5FE0-4255-B4A2-82B1AD35D662}" v="9" dt="2026-03-26T19:17:03.720"/>
   </p1510:revLst>
 </p1510:revInfo>
 </file>
@@ -292,18 +294,18 @@
   <pc:docChgLst>
     <pc:chgData name="A00043106 Amelia Stronska" userId="26b13220-5c28-497f-8887-6e4027d3be59" providerId="ADAL" clId="{431F7DB1-8E1F-4FC3-8BE5-1CB4D3E05321}"/>
     <pc:docChg chg="undo custSel addSld delSld modSld sldOrd">
-      <pc:chgData name="A00043106 Amelia Stronska" userId="26b13220-5c28-497f-8887-6e4027d3be59" providerId="ADAL" clId="{431F7DB1-8E1F-4FC3-8BE5-1CB4D3E05321}" dt="2026-03-26T18:02:25.578" v="1267" actId="14734"/>
+      <pc:chgData name="A00043106 Amelia Stronska" userId="26b13220-5c28-497f-8887-6e4027d3be59" providerId="ADAL" clId="{431F7DB1-8E1F-4FC3-8BE5-1CB4D3E05321}" dt="2026-03-26T19:18:30.154" v="1322" actId="20577"/>
       <pc:docMkLst>
         <pc:docMk/>
       </pc:docMkLst>
       <pc:sldChg chg="addSp modSp mod">
-        <pc:chgData name="A00043106 Amelia Stronska" userId="26b13220-5c28-497f-8887-6e4027d3be59" providerId="ADAL" clId="{431F7DB1-8E1F-4FC3-8BE5-1CB4D3E05321}" dt="2026-03-26T16:47:30.968" v="727" actId="20577"/>
+        <pc:chgData name="A00043106 Amelia Stronska" userId="26b13220-5c28-497f-8887-6e4027d3be59" providerId="ADAL" clId="{431F7DB1-8E1F-4FC3-8BE5-1CB4D3E05321}" dt="2026-03-26T19:18:30.154" v="1322" actId="20577"/>
         <pc:sldMkLst>
           <pc:docMk/>
           <pc:sldMk cId="0" sldId="259"/>
         </pc:sldMkLst>
         <pc:spChg chg="add mod">
-          <ac:chgData name="A00043106 Amelia Stronska" userId="26b13220-5c28-497f-8887-6e4027d3be59" providerId="ADAL" clId="{431F7DB1-8E1F-4FC3-8BE5-1CB4D3E05321}" dt="2026-03-26T16:47:10.211" v="719" actId="1076"/>
+          <ac:chgData name="A00043106 Amelia Stronska" userId="26b13220-5c28-497f-8887-6e4027d3be59" providerId="ADAL" clId="{431F7DB1-8E1F-4FC3-8BE5-1CB4D3E05321}" dt="2026-03-26T19:18:30.154" v="1322" actId="20577"/>
           <ac:spMkLst>
             <pc:docMk/>
             <pc:sldMk cId="0" sldId="259"/>
@@ -418,6 +420,43 @@
             <ac:graphicFrameMk id="4" creationId="{F19D0D98-73BD-5524-3534-B676CFF7A488}"/>
           </ac:graphicFrameMkLst>
         </pc:graphicFrameChg>
+      </pc:sldChg>
+      <pc:sldChg chg="add ord">
+        <pc:chgData name="A00043106 Amelia Stronska" userId="26b13220-5c28-497f-8887-6e4027d3be59" providerId="ADAL" clId="{431F7DB1-8E1F-4FC3-8BE5-1CB4D3E05321}" dt="2026-03-26T19:17:22.212" v="1279"/>
+        <pc:sldMkLst>
+          <pc:docMk/>
+          <pc:sldMk cId="416580211" sldId="300"/>
+        </pc:sldMkLst>
+      </pc:sldChg>
+      <pc:sldChg chg="modSp new del mod">
+        <pc:chgData name="A00043106 Amelia Stronska" userId="26b13220-5c28-497f-8887-6e4027d3be59" providerId="ADAL" clId="{431F7DB1-8E1F-4FC3-8BE5-1CB4D3E05321}" dt="2026-03-26T19:17:07.745" v="1275" actId="2696"/>
+        <pc:sldMkLst>
+          <pc:docMk/>
+          <pc:sldMk cId="4253162396" sldId="300"/>
+        </pc:sldMkLst>
+        <pc:spChg chg="mod">
+          <ac:chgData name="A00043106 Amelia Stronska" userId="26b13220-5c28-497f-8887-6e4027d3be59" providerId="ADAL" clId="{431F7DB1-8E1F-4FC3-8BE5-1CB4D3E05321}" dt="2026-03-26T19:17:03.749" v="1274" actId="27636"/>
+          <ac:spMkLst>
+            <pc:docMk/>
+            <pc:sldMk cId="4253162396" sldId="300"/>
+            <ac:spMk id="2" creationId="{2F44A6DC-A636-FE23-E98A-DF5EAC8A0E31}"/>
+          </ac:spMkLst>
+        </pc:spChg>
+        <pc:spChg chg="mod">
+          <ac:chgData name="A00043106 Amelia Stronska" userId="26b13220-5c28-497f-8887-6e4027d3be59" providerId="ADAL" clId="{431F7DB1-8E1F-4FC3-8BE5-1CB4D3E05321}" dt="2026-03-26T19:17:03.720" v="1273"/>
+          <ac:spMkLst>
+            <pc:docMk/>
+            <pc:sldMk cId="4253162396" sldId="300"/>
+            <ac:spMk id="3" creationId="{4F849FAC-E7B3-42BA-2549-003D0CD2FB90}"/>
+          </ac:spMkLst>
+        </pc:spChg>
+      </pc:sldChg>
+      <pc:sldChg chg="add ord">
+        <pc:chgData name="A00043106 Amelia Stronska" userId="26b13220-5c28-497f-8887-6e4027d3be59" providerId="ADAL" clId="{431F7DB1-8E1F-4FC3-8BE5-1CB4D3E05321}" dt="2026-03-26T19:17:27.679" v="1281"/>
+        <pc:sldMkLst>
+          <pc:docMk/>
+          <pc:sldMk cId="2263138154" sldId="301"/>
+        </pc:sldMkLst>
       </pc:sldChg>
     </pc:docChg>
   </pc:docChgLst>
@@ -7939,6 +7978,1744 @@
   <p:cSld>
     <p:spTree>
       <p:nvGrpSpPr>
+        <p:cNvPr id="1" name="">
+          <a:extLst>
+            <a:ext uri="{FF2B5EF4-FFF2-40B4-BE49-F238E27FC236}">
+              <a16:creationId xmlns:a16="http://schemas.microsoft.com/office/drawing/2014/main" id="{260CF29F-979D-B139-A766-033819458EC0}"/>
+            </a:ext>
+          </a:extLst>
+        </p:cNvPr>
+        <p:cNvGrpSpPr/>
+        <p:nvPr/>
+      </p:nvGrpSpPr>
+      <p:grpSpPr>
+        <a:xfrm>
+          <a:off x="0" y="0"/>
+          <a:ext cx="0" cy="0"/>
+          <a:chOff x="0" y="0"/>
+          <a:chExt cx="0" cy="0"/>
+        </a:xfrm>
+      </p:grpSpPr>
+      <p:sp>
+        <p:nvSpPr>
+          <p:cNvPr id="2" name="Title 1">
+            <a:extLst>
+              <a:ext uri="{FF2B5EF4-FFF2-40B4-BE49-F238E27FC236}">
+                <a16:creationId xmlns:a16="http://schemas.microsoft.com/office/drawing/2014/main" id="{DE519775-5C59-B397-168E-B216C070CFBA}"/>
+              </a:ext>
+            </a:extLst>
+          </p:cNvPr>
+          <p:cNvSpPr>
+            <a:spLocks noGrp="1"/>
+          </p:cNvSpPr>
+          <p:nvPr>
+            <p:ph type="title"/>
+          </p:nvPr>
+        </p:nvSpPr>
+        <p:spPr>
+          <a:xfrm>
+            <a:off x="311699" y="288275"/>
+            <a:ext cx="8520600" cy="572700"/>
+          </a:xfrm>
+        </p:spPr>
+        <p:txBody>
+          <a:bodyPr>
+            <a:normAutofit fontScale="90000"/>
+          </a:bodyPr>
+          <a:lstStyle/>
+          <a:p>
+            <a:r>
+              <a:rPr lang="en-IE" dirty="0"/>
+              <a:t>Continuous  </a:t>
+            </a:r>
+          </a:p>
+        </p:txBody>
+      </p:sp>
+      <p:sp>
+        <p:nvSpPr>
+          <p:cNvPr id="3" name="Text Placeholder 2">
+            <a:extLst>
+              <a:ext uri="{FF2B5EF4-FFF2-40B4-BE49-F238E27FC236}">
+                <a16:creationId xmlns:a16="http://schemas.microsoft.com/office/drawing/2014/main" id="{3DEA187F-DC49-18BC-296A-7A6B88F9CE68}"/>
+              </a:ext>
+            </a:extLst>
+          </p:cNvPr>
+          <p:cNvSpPr>
+            <a:spLocks noGrp="1"/>
+          </p:cNvSpPr>
+          <p:nvPr>
+            <p:ph type="body" idx="1"/>
+          </p:nvPr>
+        </p:nvSpPr>
+        <p:spPr/>
+        <p:txBody>
+          <a:bodyPr/>
+          <a:lstStyle/>
+          <a:p>
+            <a:endParaRPr lang="en-IE"/>
+          </a:p>
+        </p:txBody>
+      </p:sp>
+      <p:graphicFrame>
+        <p:nvGraphicFramePr>
+          <p:cNvPr id="4" name="Table 3">
+            <a:extLst>
+              <a:ext uri="{FF2B5EF4-FFF2-40B4-BE49-F238E27FC236}">
+                <a16:creationId xmlns:a16="http://schemas.microsoft.com/office/drawing/2014/main" id="{AEEAF7DB-DC94-75D1-DCB7-BFB2CFC9F121}"/>
+              </a:ext>
+            </a:extLst>
+          </p:cNvPr>
+          <p:cNvGraphicFramePr>
+            <a:graphicFrameLocks noGrp="1"/>
+          </p:cNvGraphicFramePr>
+          <p:nvPr/>
+        </p:nvGraphicFramePr>
+        <p:xfrm>
+          <a:off x="187779" y="1152475"/>
+          <a:ext cx="8768441" cy="3864655"/>
+        </p:xfrm>
+        <a:graphic>
+          <a:graphicData uri="http://schemas.openxmlformats.org/drawingml/2006/table">
+            <a:tbl>
+              <a:tblPr firstRow="1" bandRow="1">
+                <a:tableStyleId>{7DF18680-E054-41AD-8BC1-D1AEF772440D}</a:tableStyleId>
+              </a:tblPr>
+              <a:tblGrid>
+                <a:gridCol w="797131">
+                  <a:extLst>
+                    <a:ext uri="{9D8B030D-6E8A-4147-A177-3AD203B41FA5}">
+                      <a16:colId xmlns:a16="http://schemas.microsoft.com/office/drawing/2014/main" val="2275553917"/>
+                    </a:ext>
+                  </a:extLst>
+                </a:gridCol>
+                <a:gridCol w="797131">
+                  <a:extLst>
+                    <a:ext uri="{9D8B030D-6E8A-4147-A177-3AD203B41FA5}">
+                      <a16:colId xmlns:a16="http://schemas.microsoft.com/office/drawing/2014/main" val="3348065387"/>
+                    </a:ext>
+                  </a:extLst>
+                </a:gridCol>
+                <a:gridCol w="797131">
+                  <a:extLst>
+                    <a:ext uri="{9D8B030D-6E8A-4147-A177-3AD203B41FA5}">
+                      <a16:colId xmlns:a16="http://schemas.microsoft.com/office/drawing/2014/main" val="2818657339"/>
+                    </a:ext>
+                  </a:extLst>
+                </a:gridCol>
+                <a:gridCol w="797131">
+                  <a:extLst>
+                    <a:ext uri="{9D8B030D-6E8A-4147-A177-3AD203B41FA5}">
+                      <a16:colId xmlns:a16="http://schemas.microsoft.com/office/drawing/2014/main" val="3766553928"/>
+                    </a:ext>
+                  </a:extLst>
+                </a:gridCol>
+                <a:gridCol w="797131">
+                  <a:extLst>
+                    <a:ext uri="{9D8B030D-6E8A-4147-A177-3AD203B41FA5}">
+                      <a16:colId xmlns:a16="http://schemas.microsoft.com/office/drawing/2014/main" val="983292674"/>
+                    </a:ext>
+                  </a:extLst>
+                </a:gridCol>
+                <a:gridCol w="797131">
+                  <a:extLst>
+                    <a:ext uri="{9D8B030D-6E8A-4147-A177-3AD203B41FA5}">
+                      <a16:colId xmlns:a16="http://schemas.microsoft.com/office/drawing/2014/main" val="667248982"/>
+                    </a:ext>
+                  </a:extLst>
+                </a:gridCol>
+                <a:gridCol w="797131">
+                  <a:extLst>
+                    <a:ext uri="{9D8B030D-6E8A-4147-A177-3AD203B41FA5}">
+                      <a16:colId xmlns:a16="http://schemas.microsoft.com/office/drawing/2014/main" val="3443807263"/>
+                    </a:ext>
+                  </a:extLst>
+                </a:gridCol>
+                <a:gridCol w="797131">
+                  <a:extLst>
+                    <a:ext uri="{9D8B030D-6E8A-4147-A177-3AD203B41FA5}">
+                      <a16:colId xmlns:a16="http://schemas.microsoft.com/office/drawing/2014/main" val="2215435004"/>
+                    </a:ext>
+                  </a:extLst>
+                </a:gridCol>
+                <a:gridCol w="797131">
+                  <a:extLst>
+                    <a:ext uri="{9D8B030D-6E8A-4147-A177-3AD203B41FA5}">
+                      <a16:colId xmlns:a16="http://schemas.microsoft.com/office/drawing/2014/main" val="1790629358"/>
+                    </a:ext>
+                  </a:extLst>
+                </a:gridCol>
+                <a:gridCol w="797131">
+                  <a:extLst>
+                    <a:ext uri="{9D8B030D-6E8A-4147-A177-3AD203B41FA5}">
+                      <a16:colId xmlns:a16="http://schemas.microsoft.com/office/drawing/2014/main" val="3438624279"/>
+                    </a:ext>
+                  </a:extLst>
+                </a:gridCol>
+                <a:gridCol w="797131">
+                  <a:extLst>
+                    <a:ext uri="{9D8B030D-6E8A-4147-A177-3AD203B41FA5}">
+                      <a16:colId xmlns:a16="http://schemas.microsoft.com/office/drawing/2014/main" val="1505714332"/>
+                    </a:ext>
+                  </a:extLst>
+                </a:gridCol>
+              </a:tblGrid>
+              <a:tr h="772931">
+                <a:tc>
+                  <a:txBody>
+                    <a:bodyPr/>
+                    <a:lstStyle/>
+                    <a:p>
+                      <a:r>
+                        <a:rPr lang="en-IE" sz="1200" dirty="0"/>
+                        <a:t>Feature</a:t>
+                      </a:r>
+                    </a:p>
+                  </a:txBody>
+                  <a:tcPr/>
+                </a:tc>
+                <a:tc>
+                  <a:txBody>
+                    <a:bodyPr/>
+                    <a:lstStyle/>
+                    <a:p>
+                      <a:r>
+                        <a:rPr lang="en-IE" sz="1200" dirty="0"/>
+                        <a:t>Count </a:t>
+                      </a:r>
+                    </a:p>
+                  </a:txBody>
+                  <a:tcPr/>
+                </a:tc>
+                <a:tc>
+                  <a:txBody>
+                    <a:bodyPr/>
+                    <a:lstStyle/>
+                    <a:p>
+                      <a:r>
+                        <a:rPr lang="en-IE" sz="1200" dirty="0"/>
+                        <a:t>%Missing</a:t>
+                      </a:r>
+                    </a:p>
+                  </a:txBody>
+                  <a:tcPr/>
+                </a:tc>
+                <a:tc>
+                  <a:txBody>
+                    <a:bodyPr/>
+                    <a:lstStyle/>
+                    <a:p>
+                      <a:r>
+                        <a:rPr lang="en-IE" sz="1200" dirty="0"/>
+                        <a:t>Card </a:t>
+                      </a:r>
+                    </a:p>
+                  </a:txBody>
+                  <a:tcPr/>
+                </a:tc>
+                <a:tc>
+                  <a:txBody>
+                    <a:bodyPr/>
+                    <a:lstStyle/>
+                    <a:p>
+                      <a:r>
+                        <a:rPr lang="en-IE" sz="1200" dirty="0"/>
+                        <a:t>Min </a:t>
+                      </a:r>
+                    </a:p>
+                  </a:txBody>
+                  <a:tcPr/>
+                </a:tc>
+                <a:tc>
+                  <a:txBody>
+                    <a:bodyPr/>
+                    <a:lstStyle/>
+                    <a:p>
+                      <a:r>
+                        <a:rPr lang="en-IE" sz="1200" dirty="0"/>
+                        <a:t>1</a:t>
+                      </a:r>
+                      <a:r>
+                        <a:rPr lang="en-IE" sz="1200" baseline="30000" dirty="0"/>
+                        <a:t>st</a:t>
+                      </a:r>
+                      <a:r>
+                        <a:rPr lang="en-IE" sz="1200" dirty="0"/>
+                        <a:t> </a:t>
+                      </a:r>
+                      <a:r>
+                        <a:rPr lang="en-IE" sz="1200" dirty="0" err="1"/>
+                        <a:t>Qrt</a:t>
+                      </a:r>
+                      <a:r>
+                        <a:rPr lang="en-IE" sz="1200" dirty="0"/>
+                        <a:t>.</a:t>
+                      </a:r>
+                    </a:p>
+                  </a:txBody>
+                  <a:tcPr/>
+                </a:tc>
+                <a:tc>
+                  <a:txBody>
+                    <a:bodyPr/>
+                    <a:lstStyle/>
+                    <a:p>
+                      <a:r>
+                        <a:rPr lang="en-IE" sz="1200" dirty="0"/>
+                        <a:t>Mean</a:t>
+                      </a:r>
+                    </a:p>
+                  </a:txBody>
+                  <a:tcPr/>
+                </a:tc>
+                <a:tc>
+                  <a:txBody>
+                    <a:bodyPr/>
+                    <a:lstStyle/>
+                    <a:p>
+                      <a:r>
+                        <a:rPr lang="en-IE" sz="1200" dirty="0"/>
+                        <a:t>Median </a:t>
+                      </a:r>
+                    </a:p>
+                  </a:txBody>
+                  <a:tcPr/>
+                </a:tc>
+                <a:tc>
+                  <a:txBody>
+                    <a:bodyPr/>
+                    <a:lstStyle/>
+                    <a:p>
+                      <a:r>
+                        <a:rPr lang="en-IE" sz="1200" dirty="0"/>
+                        <a:t>3</a:t>
+                      </a:r>
+                      <a:r>
+                        <a:rPr lang="en-IE" sz="1200" baseline="30000" dirty="0"/>
+                        <a:t>rd</a:t>
+                      </a:r>
+                      <a:r>
+                        <a:rPr lang="en-IE" sz="1200" dirty="0"/>
+                        <a:t> </a:t>
+                      </a:r>
+                      <a:r>
+                        <a:rPr lang="en-IE" sz="1200" dirty="0" err="1"/>
+                        <a:t>Qrt</a:t>
+                      </a:r>
+                      <a:r>
+                        <a:rPr lang="en-IE" sz="1200" dirty="0"/>
+                        <a:t>.</a:t>
+                      </a:r>
+                    </a:p>
+                  </a:txBody>
+                  <a:tcPr/>
+                </a:tc>
+                <a:tc>
+                  <a:txBody>
+                    <a:bodyPr/>
+                    <a:lstStyle/>
+                    <a:p>
+                      <a:r>
+                        <a:rPr lang="en-IE" sz="1200" dirty="0"/>
+                        <a:t>Max </a:t>
+                      </a:r>
+                    </a:p>
+                  </a:txBody>
+                  <a:tcPr/>
+                </a:tc>
+                <a:tc>
+                  <a:txBody>
+                    <a:bodyPr/>
+                    <a:lstStyle/>
+                    <a:p>
+                      <a:r>
+                        <a:rPr lang="en-IE" sz="1200" dirty="0"/>
+                        <a:t>Std Dev.</a:t>
+                      </a:r>
+                    </a:p>
+                  </a:txBody>
+                  <a:tcPr/>
+                </a:tc>
+                <a:extLst>
+                  <a:ext uri="{0D108BD9-81ED-4DB2-BD59-A6C34878D82A}">
+                    <a16:rowId xmlns:a16="http://schemas.microsoft.com/office/drawing/2014/main" val="2952155696"/>
+                  </a:ext>
+                </a:extLst>
+              </a:tr>
+              <a:tr h="772931">
+                <a:tc>
+                  <a:txBody>
+                    <a:bodyPr/>
+                    <a:lstStyle/>
+                    <a:p>
+                      <a:r>
+                        <a:rPr lang="en-IE" sz="1200" dirty="0"/>
+                        <a:t>Rating </a:t>
+                      </a:r>
+                    </a:p>
+                  </a:txBody>
+                  <a:tcPr/>
+                </a:tc>
+                <a:tc>
+                  <a:txBody>
+                    <a:bodyPr/>
+                    <a:lstStyle/>
+                    <a:p>
+                      <a:endParaRPr lang="en-IE" dirty="0"/>
+                    </a:p>
+                  </a:txBody>
+                  <a:tcPr/>
+                </a:tc>
+                <a:tc>
+                  <a:txBody>
+                    <a:bodyPr/>
+                    <a:lstStyle/>
+                    <a:p>
+                      <a:endParaRPr lang="en-IE"/>
+                    </a:p>
+                  </a:txBody>
+                  <a:tcPr/>
+                </a:tc>
+                <a:tc>
+                  <a:txBody>
+                    <a:bodyPr/>
+                    <a:lstStyle/>
+                    <a:p>
+                      <a:endParaRPr lang="en-IE"/>
+                    </a:p>
+                  </a:txBody>
+                  <a:tcPr/>
+                </a:tc>
+                <a:tc>
+                  <a:txBody>
+                    <a:bodyPr/>
+                    <a:lstStyle/>
+                    <a:p>
+                      <a:endParaRPr lang="en-IE"/>
+                    </a:p>
+                  </a:txBody>
+                  <a:tcPr/>
+                </a:tc>
+                <a:tc>
+                  <a:txBody>
+                    <a:bodyPr/>
+                    <a:lstStyle/>
+                    <a:p>
+                      <a:endParaRPr lang="en-IE" dirty="0"/>
+                    </a:p>
+                  </a:txBody>
+                  <a:tcPr/>
+                </a:tc>
+                <a:tc>
+                  <a:txBody>
+                    <a:bodyPr/>
+                    <a:lstStyle/>
+                    <a:p>
+                      <a:endParaRPr lang="en-IE"/>
+                    </a:p>
+                  </a:txBody>
+                  <a:tcPr/>
+                </a:tc>
+                <a:tc>
+                  <a:txBody>
+                    <a:bodyPr/>
+                    <a:lstStyle/>
+                    <a:p>
+                      <a:endParaRPr lang="en-IE"/>
+                    </a:p>
+                  </a:txBody>
+                  <a:tcPr/>
+                </a:tc>
+                <a:tc>
+                  <a:txBody>
+                    <a:bodyPr/>
+                    <a:lstStyle/>
+                    <a:p>
+                      <a:endParaRPr lang="en-IE"/>
+                    </a:p>
+                  </a:txBody>
+                  <a:tcPr/>
+                </a:tc>
+                <a:tc>
+                  <a:txBody>
+                    <a:bodyPr/>
+                    <a:lstStyle/>
+                    <a:p>
+                      <a:endParaRPr lang="en-IE"/>
+                    </a:p>
+                  </a:txBody>
+                  <a:tcPr/>
+                </a:tc>
+                <a:tc>
+                  <a:txBody>
+                    <a:bodyPr/>
+                    <a:lstStyle/>
+                    <a:p>
+                      <a:endParaRPr lang="en-IE"/>
+                    </a:p>
+                  </a:txBody>
+                  <a:tcPr/>
+                </a:tc>
+                <a:extLst>
+                  <a:ext uri="{0D108BD9-81ED-4DB2-BD59-A6C34878D82A}">
+                    <a16:rowId xmlns:a16="http://schemas.microsoft.com/office/drawing/2014/main" val="4276670550"/>
+                  </a:ext>
+                </a:extLst>
+              </a:tr>
+              <a:tr h="772931">
+                <a:tc>
+                  <a:txBody>
+                    <a:bodyPr/>
+                    <a:lstStyle/>
+                    <a:p>
+                      <a:r>
+                        <a:rPr lang="en-IE" sz="1200" dirty="0"/>
+                        <a:t>Votes </a:t>
+                      </a:r>
+                    </a:p>
+                  </a:txBody>
+                  <a:tcPr/>
+                </a:tc>
+                <a:tc>
+                  <a:txBody>
+                    <a:bodyPr/>
+                    <a:lstStyle/>
+                    <a:p>
+                      <a:endParaRPr lang="en-IE"/>
+                    </a:p>
+                  </a:txBody>
+                  <a:tcPr/>
+                </a:tc>
+                <a:tc>
+                  <a:txBody>
+                    <a:bodyPr/>
+                    <a:lstStyle/>
+                    <a:p>
+                      <a:endParaRPr lang="en-IE"/>
+                    </a:p>
+                  </a:txBody>
+                  <a:tcPr/>
+                </a:tc>
+                <a:tc>
+                  <a:txBody>
+                    <a:bodyPr/>
+                    <a:lstStyle/>
+                    <a:p>
+                      <a:endParaRPr lang="en-IE" dirty="0"/>
+                    </a:p>
+                  </a:txBody>
+                  <a:tcPr/>
+                </a:tc>
+                <a:tc>
+                  <a:txBody>
+                    <a:bodyPr/>
+                    <a:lstStyle/>
+                    <a:p>
+                      <a:endParaRPr lang="en-IE"/>
+                    </a:p>
+                  </a:txBody>
+                  <a:tcPr/>
+                </a:tc>
+                <a:tc>
+                  <a:txBody>
+                    <a:bodyPr/>
+                    <a:lstStyle/>
+                    <a:p>
+                      <a:endParaRPr lang="en-IE"/>
+                    </a:p>
+                  </a:txBody>
+                  <a:tcPr/>
+                </a:tc>
+                <a:tc>
+                  <a:txBody>
+                    <a:bodyPr/>
+                    <a:lstStyle/>
+                    <a:p>
+                      <a:endParaRPr lang="en-IE"/>
+                    </a:p>
+                  </a:txBody>
+                  <a:tcPr/>
+                </a:tc>
+                <a:tc>
+                  <a:txBody>
+                    <a:bodyPr/>
+                    <a:lstStyle/>
+                    <a:p>
+                      <a:endParaRPr lang="en-IE"/>
+                    </a:p>
+                  </a:txBody>
+                  <a:tcPr/>
+                </a:tc>
+                <a:tc>
+                  <a:txBody>
+                    <a:bodyPr/>
+                    <a:lstStyle/>
+                    <a:p>
+                      <a:endParaRPr lang="en-IE"/>
+                    </a:p>
+                  </a:txBody>
+                  <a:tcPr/>
+                </a:tc>
+                <a:tc>
+                  <a:txBody>
+                    <a:bodyPr/>
+                    <a:lstStyle/>
+                    <a:p>
+                      <a:endParaRPr lang="en-IE"/>
+                    </a:p>
+                  </a:txBody>
+                  <a:tcPr/>
+                </a:tc>
+                <a:tc>
+                  <a:txBody>
+                    <a:bodyPr/>
+                    <a:lstStyle/>
+                    <a:p>
+                      <a:endParaRPr lang="en-IE"/>
+                    </a:p>
+                  </a:txBody>
+                  <a:tcPr/>
+                </a:tc>
+                <a:extLst>
+                  <a:ext uri="{0D108BD9-81ED-4DB2-BD59-A6C34878D82A}">
+                    <a16:rowId xmlns:a16="http://schemas.microsoft.com/office/drawing/2014/main" val="1893299196"/>
+                  </a:ext>
+                </a:extLst>
+              </a:tr>
+              <a:tr h="772931">
+                <a:tc>
+                  <a:txBody>
+                    <a:bodyPr/>
+                    <a:lstStyle/>
+                    <a:p>
+                      <a:r>
+                        <a:rPr lang="en-IE" sz="1200" dirty="0"/>
+                        <a:t>Runtime </a:t>
+                      </a:r>
+                    </a:p>
+                  </a:txBody>
+                  <a:tcPr/>
+                </a:tc>
+                <a:tc>
+                  <a:txBody>
+                    <a:bodyPr/>
+                    <a:lstStyle/>
+                    <a:p>
+                      <a:endParaRPr lang="en-IE" dirty="0"/>
+                    </a:p>
+                  </a:txBody>
+                  <a:tcPr/>
+                </a:tc>
+                <a:tc>
+                  <a:txBody>
+                    <a:bodyPr/>
+                    <a:lstStyle/>
+                    <a:p>
+                      <a:endParaRPr lang="en-IE"/>
+                    </a:p>
+                  </a:txBody>
+                  <a:tcPr/>
+                </a:tc>
+                <a:tc>
+                  <a:txBody>
+                    <a:bodyPr/>
+                    <a:lstStyle/>
+                    <a:p>
+                      <a:endParaRPr lang="en-IE"/>
+                    </a:p>
+                  </a:txBody>
+                  <a:tcPr/>
+                </a:tc>
+                <a:tc>
+                  <a:txBody>
+                    <a:bodyPr/>
+                    <a:lstStyle/>
+                    <a:p>
+                      <a:endParaRPr lang="en-IE"/>
+                    </a:p>
+                  </a:txBody>
+                  <a:tcPr/>
+                </a:tc>
+                <a:tc>
+                  <a:txBody>
+                    <a:bodyPr/>
+                    <a:lstStyle/>
+                    <a:p>
+                      <a:endParaRPr lang="en-IE"/>
+                    </a:p>
+                  </a:txBody>
+                  <a:tcPr/>
+                </a:tc>
+                <a:tc>
+                  <a:txBody>
+                    <a:bodyPr/>
+                    <a:lstStyle/>
+                    <a:p>
+                      <a:endParaRPr lang="en-IE"/>
+                    </a:p>
+                  </a:txBody>
+                  <a:tcPr/>
+                </a:tc>
+                <a:tc>
+                  <a:txBody>
+                    <a:bodyPr/>
+                    <a:lstStyle/>
+                    <a:p>
+                      <a:endParaRPr lang="en-IE"/>
+                    </a:p>
+                  </a:txBody>
+                  <a:tcPr/>
+                </a:tc>
+                <a:tc>
+                  <a:txBody>
+                    <a:bodyPr/>
+                    <a:lstStyle/>
+                    <a:p>
+                      <a:endParaRPr lang="en-IE"/>
+                    </a:p>
+                  </a:txBody>
+                  <a:tcPr/>
+                </a:tc>
+                <a:tc>
+                  <a:txBody>
+                    <a:bodyPr/>
+                    <a:lstStyle/>
+                    <a:p>
+                      <a:endParaRPr lang="en-IE"/>
+                    </a:p>
+                  </a:txBody>
+                  <a:tcPr/>
+                </a:tc>
+                <a:tc>
+                  <a:txBody>
+                    <a:bodyPr/>
+                    <a:lstStyle/>
+                    <a:p>
+                      <a:endParaRPr lang="en-IE" dirty="0"/>
+                    </a:p>
+                  </a:txBody>
+                  <a:tcPr/>
+                </a:tc>
+                <a:extLst>
+                  <a:ext uri="{0D108BD9-81ED-4DB2-BD59-A6C34878D82A}">
+                    <a16:rowId xmlns:a16="http://schemas.microsoft.com/office/drawing/2014/main" val="3659900118"/>
+                  </a:ext>
+                </a:extLst>
+              </a:tr>
+              <a:tr h="772931">
+                <a:tc>
+                  <a:txBody>
+                    <a:bodyPr/>
+                    <a:lstStyle/>
+                    <a:p>
+                      <a:r>
+                        <a:rPr lang="en-IE" sz="1200" dirty="0"/>
+                        <a:t>Gross Income </a:t>
+                      </a:r>
+                    </a:p>
+                  </a:txBody>
+                  <a:tcPr/>
+                </a:tc>
+                <a:tc>
+                  <a:txBody>
+                    <a:bodyPr/>
+                    <a:lstStyle/>
+                    <a:p>
+                      <a:endParaRPr lang="en-IE"/>
+                    </a:p>
+                  </a:txBody>
+                  <a:tcPr/>
+                </a:tc>
+                <a:tc>
+                  <a:txBody>
+                    <a:bodyPr/>
+                    <a:lstStyle/>
+                    <a:p>
+                      <a:endParaRPr lang="en-IE"/>
+                    </a:p>
+                  </a:txBody>
+                  <a:tcPr/>
+                </a:tc>
+                <a:tc>
+                  <a:txBody>
+                    <a:bodyPr/>
+                    <a:lstStyle/>
+                    <a:p>
+                      <a:endParaRPr lang="en-IE"/>
+                    </a:p>
+                  </a:txBody>
+                  <a:tcPr/>
+                </a:tc>
+                <a:tc>
+                  <a:txBody>
+                    <a:bodyPr/>
+                    <a:lstStyle/>
+                    <a:p>
+                      <a:endParaRPr lang="en-IE"/>
+                    </a:p>
+                  </a:txBody>
+                  <a:tcPr/>
+                </a:tc>
+                <a:tc>
+                  <a:txBody>
+                    <a:bodyPr/>
+                    <a:lstStyle/>
+                    <a:p>
+                      <a:endParaRPr lang="en-IE"/>
+                    </a:p>
+                  </a:txBody>
+                  <a:tcPr/>
+                </a:tc>
+                <a:tc>
+                  <a:txBody>
+                    <a:bodyPr/>
+                    <a:lstStyle/>
+                    <a:p>
+                      <a:endParaRPr lang="en-IE"/>
+                    </a:p>
+                  </a:txBody>
+                  <a:tcPr/>
+                </a:tc>
+                <a:tc>
+                  <a:txBody>
+                    <a:bodyPr/>
+                    <a:lstStyle/>
+                    <a:p>
+                      <a:endParaRPr lang="en-IE"/>
+                    </a:p>
+                  </a:txBody>
+                  <a:tcPr/>
+                </a:tc>
+                <a:tc>
+                  <a:txBody>
+                    <a:bodyPr/>
+                    <a:lstStyle/>
+                    <a:p>
+                      <a:endParaRPr lang="en-IE"/>
+                    </a:p>
+                  </a:txBody>
+                  <a:tcPr/>
+                </a:tc>
+                <a:tc>
+                  <a:txBody>
+                    <a:bodyPr/>
+                    <a:lstStyle/>
+                    <a:p>
+                      <a:endParaRPr lang="en-IE"/>
+                    </a:p>
+                  </a:txBody>
+                  <a:tcPr/>
+                </a:tc>
+                <a:tc>
+                  <a:txBody>
+                    <a:bodyPr/>
+                    <a:lstStyle/>
+                    <a:p>
+                      <a:endParaRPr lang="en-IE" dirty="0"/>
+                    </a:p>
+                  </a:txBody>
+                  <a:tcPr/>
+                </a:tc>
+                <a:extLst>
+                  <a:ext uri="{0D108BD9-81ED-4DB2-BD59-A6C34878D82A}">
+                    <a16:rowId xmlns:a16="http://schemas.microsoft.com/office/drawing/2014/main" val="438441145"/>
+                  </a:ext>
+                </a:extLst>
+              </a:tr>
+            </a:tbl>
+          </a:graphicData>
+        </a:graphic>
+      </p:graphicFrame>
+    </p:spTree>
+    <p:extLst>
+      <p:ext uri="{BB962C8B-B14F-4D97-AF65-F5344CB8AC3E}">
+        <p14:creationId xmlns:p14="http://schemas.microsoft.com/office/powerpoint/2010/main" val="416580211"/>
+      </p:ext>
+    </p:extLst>
+  </p:cSld>
+  <p:clrMapOvr>
+    <a:masterClrMapping/>
+  </p:clrMapOvr>
+</p:sld>
+</file>
+
+<file path=ppt/slides/slide14.xml><?xml version="1.0" encoding="utf-8"?>
+<p:sld xmlns:a="http://schemas.openxmlformats.org/drawingml/2006/main" xmlns:r="http://schemas.openxmlformats.org/officeDocument/2006/relationships" xmlns:p="http://schemas.openxmlformats.org/presentationml/2006/main">
+  <p:cSld>
+    <p:spTree>
+      <p:nvGrpSpPr>
+        <p:cNvPr id="1" name="">
+          <a:extLst>
+            <a:ext uri="{FF2B5EF4-FFF2-40B4-BE49-F238E27FC236}">
+              <a16:creationId xmlns:a16="http://schemas.microsoft.com/office/drawing/2014/main" id="{A32FDDF4-EB37-DC57-5E59-1AB73BD83C77}"/>
+            </a:ext>
+          </a:extLst>
+        </p:cNvPr>
+        <p:cNvGrpSpPr/>
+        <p:nvPr/>
+      </p:nvGrpSpPr>
+      <p:grpSpPr>
+        <a:xfrm>
+          <a:off x="0" y="0"/>
+          <a:ext cx="0" cy="0"/>
+          <a:chOff x="0" y="0"/>
+          <a:chExt cx="0" cy="0"/>
+        </a:xfrm>
+      </p:grpSpPr>
+      <p:sp>
+        <p:nvSpPr>
+          <p:cNvPr id="2" name="Title 1">
+            <a:extLst>
+              <a:ext uri="{FF2B5EF4-FFF2-40B4-BE49-F238E27FC236}">
+                <a16:creationId xmlns:a16="http://schemas.microsoft.com/office/drawing/2014/main" id="{4A43D4AC-DF64-D142-6BC7-1B5F0F5A9A64}"/>
+              </a:ext>
+            </a:extLst>
+          </p:cNvPr>
+          <p:cNvSpPr>
+            <a:spLocks noGrp="1"/>
+          </p:cNvSpPr>
+          <p:nvPr>
+            <p:ph type="title"/>
+          </p:nvPr>
+        </p:nvSpPr>
+        <p:spPr>
+          <a:xfrm>
+            <a:off x="311699" y="288275"/>
+            <a:ext cx="8520600" cy="572700"/>
+          </a:xfrm>
+        </p:spPr>
+        <p:txBody>
+          <a:bodyPr>
+            <a:normAutofit fontScale="90000"/>
+          </a:bodyPr>
+          <a:lstStyle/>
+          <a:p>
+            <a:r>
+              <a:rPr lang="en-IE" dirty="0"/>
+              <a:t>Categorical </a:t>
+            </a:r>
+          </a:p>
+        </p:txBody>
+      </p:sp>
+      <p:sp>
+        <p:nvSpPr>
+          <p:cNvPr id="3" name="Text Placeholder 2">
+            <a:extLst>
+              <a:ext uri="{FF2B5EF4-FFF2-40B4-BE49-F238E27FC236}">
+                <a16:creationId xmlns:a16="http://schemas.microsoft.com/office/drawing/2014/main" id="{6AD77C3B-7CC3-6E9A-A527-FED581310BE2}"/>
+              </a:ext>
+            </a:extLst>
+          </p:cNvPr>
+          <p:cNvSpPr>
+            <a:spLocks noGrp="1"/>
+          </p:cNvSpPr>
+          <p:nvPr>
+            <p:ph type="body" idx="1"/>
+          </p:nvPr>
+        </p:nvSpPr>
+        <p:spPr/>
+        <p:txBody>
+          <a:bodyPr/>
+          <a:lstStyle/>
+          <a:p>
+            <a:endParaRPr lang="en-IE"/>
+          </a:p>
+        </p:txBody>
+      </p:sp>
+      <p:graphicFrame>
+        <p:nvGraphicFramePr>
+          <p:cNvPr id="4" name="Table 3">
+            <a:extLst>
+              <a:ext uri="{FF2B5EF4-FFF2-40B4-BE49-F238E27FC236}">
+                <a16:creationId xmlns:a16="http://schemas.microsoft.com/office/drawing/2014/main" id="{D39349BA-4085-FC34-05C5-4C11A22FA34B}"/>
+              </a:ext>
+            </a:extLst>
+          </p:cNvPr>
+          <p:cNvGraphicFramePr>
+            <a:graphicFrameLocks noGrp="1"/>
+          </p:cNvGraphicFramePr>
+          <p:nvPr/>
+        </p:nvGraphicFramePr>
+        <p:xfrm>
+          <a:off x="179614" y="1152475"/>
+          <a:ext cx="8776606" cy="3864655"/>
+        </p:xfrm>
+        <a:graphic>
+          <a:graphicData uri="http://schemas.openxmlformats.org/drawingml/2006/table">
+            <a:tbl>
+              <a:tblPr firstRow="1" bandRow="1">
+                <a:tableStyleId>{7DF18680-E054-41AD-8BC1-D1AEF772440D}</a:tableStyleId>
+              </a:tblPr>
+              <a:tblGrid>
+                <a:gridCol w="947057">
+                  <a:extLst>
+                    <a:ext uri="{9D8B030D-6E8A-4147-A177-3AD203B41FA5}">
+                      <a16:colId xmlns:a16="http://schemas.microsoft.com/office/drawing/2014/main" val="2275553917"/>
+                    </a:ext>
+                  </a:extLst>
+                </a:gridCol>
+                <a:gridCol w="718458">
+                  <a:extLst>
+                    <a:ext uri="{9D8B030D-6E8A-4147-A177-3AD203B41FA5}">
+                      <a16:colId xmlns:a16="http://schemas.microsoft.com/office/drawing/2014/main" val="3348065387"/>
+                    </a:ext>
+                  </a:extLst>
+                </a:gridCol>
+                <a:gridCol w="734043">
+                  <a:extLst>
+                    <a:ext uri="{9D8B030D-6E8A-4147-A177-3AD203B41FA5}">
+                      <a16:colId xmlns:a16="http://schemas.microsoft.com/office/drawing/2014/main" val="2818657339"/>
+                    </a:ext>
+                  </a:extLst>
+                </a:gridCol>
+                <a:gridCol w="797131">
+                  <a:extLst>
+                    <a:ext uri="{9D8B030D-6E8A-4147-A177-3AD203B41FA5}">
+                      <a16:colId xmlns:a16="http://schemas.microsoft.com/office/drawing/2014/main" val="3766553928"/>
+                    </a:ext>
+                  </a:extLst>
+                </a:gridCol>
+                <a:gridCol w="797131">
+                  <a:extLst>
+                    <a:ext uri="{9D8B030D-6E8A-4147-A177-3AD203B41FA5}">
+                      <a16:colId xmlns:a16="http://schemas.microsoft.com/office/drawing/2014/main" val="983292674"/>
+                    </a:ext>
+                  </a:extLst>
+                </a:gridCol>
+                <a:gridCol w="797131">
+                  <a:extLst>
+                    <a:ext uri="{9D8B030D-6E8A-4147-A177-3AD203B41FA5}">
+                      <a16:colId xmlns:a16="http://schemas.microsoft.com/office/drawing/2014/main" val="667248982"/>
+                    </a:ext>
+                  </a:extLst>
+                </a:gridCol>
+                <a:gridCol w="797131">
+                  <a:extLst>
+                    <a:ext uri="{9D8B030D-6E8A-4147-A177-3AD203B41FA5}">
+                      <a16:colId xmlns:a16="http://schemas.microsoft.com/office/drawing/2014/main" val="3443807263"/>
+                    </a:ext>
+                  </a:extLst>
+                </a:gridCol>
+                <a:gridCol w="797131">
+                  <a:extLst>
+                    <a:ext uri="{9D8B030D-6E8A-4147-A177-3AD203B41FA5}">
+                      <a16:colId xmlns:a16="http://schemas.microsoft.com/office/drawing/2014/main" val="2215435004"/>
+                    </a:ext>
+                  </a:extLst>
+                </a:gridCol>
+                <a:gridCol w="797131">
+                  <a:extLst>
+                    <a:ext uri="{9D8B030D-6E8A-4147-A177-3AD203B41FA5}">
+                      <a16:colId xmlns:a16="http://schemas.microsoft.com/office/drawing/2014/main" val="1790629358"/>
+                    </a:ext>
+                  </a:extLst>
+                </a:gridCol>
+                <a:gridCol w="797131">
+                  <a:extLst>
+                    <a:ext uri="{9D8B030D-6E8A-4147-A177-3AD203B41FA5}">
+                      <a16:colId xmlns:a16="http://schemas.microsoft.com/office/drawing/2014/main" val="3438624279"/>
+                    </a:ext>
+                  </a:extLst>
+                </a:gridCol>
+                <a:gridCol w="797131">
+                  <a:extLst>
+                    <a:ext uri="{9D8B030D-6E8A-4147-A177-3AD203B41FA5}">
+                      <a16:colId xmlns:a16="http://schemas.microsoft.com/office/drawing/2014/main" val="1505714332"/>
+                    </a:ext>
+                  </a:extLst>
+                </a:gridCol>
+              </a:tblGrid>
+              <a:tr h="772931">
+                <a:tc>
+                  <a:txBody>
+                    <a:bodyPr/>
+                    <a:lstStyle/>
+                    <a:p>
+                      <a:r>
+                        <a:rPr lang="en-IE" sz="1200" dirty="0"/>
+                        <a:t>Feature</a:t>
+                      </a:r>
+                    </a:p>
+                  </a:txBody>
+                  <a:tcPr/>
+                </a:tc>
+                <a:tc>
+                  <a:txBody>
+                    <a:bodyPr/>
+                    <a:lstStyle/>
+                    <a:p>
+                      <a:r>
+                        <a:rPr lang="en-IE" sz="1200" dirty="0"/>
+                        <a:t>Count </a:t>
+                      </a:r>
+                    </a:p>
+                  </a:txBody>
+                  <a:tcPr/>
+                </a:tc>
+                <a:tc>
+                  <a:txBody>
+                    <a:bodyPr/>
+                    <a:lstStyle/>
+                    <a:p>
+                      <a:r>
+                        <a:rPr lang="en-IE" sz="1200" dirty="0"/>
+                        <a:t>%Missing</a:t>
+                      </a:r>
+                    </a:p>
+                  </a:txBody>
+                  <a:tcPr/>
+                </a:tc>
+                <a:tc>
+                  <a:txBody>
+                    <a:bodyPr/>
+                    <a:lstStyle/>
+                    <a:p>
+                      <a:r>
+                        <a:rPr lang="en-IE" sz="1200" dirty="0"/>
+                        <a:t>Card </a:t>
+                      </a:r>
+                    </a:p>
+                  </a:txBody>
+                  <a:tcPr/>
+                </a:tc>
+                <a:tc>
+                  <a:txBody>
+                    <a:bodyPr/>
+                    <a:lstStyle/>
+                    <a:p>
+                      <a:r>
+                        <a:rPr lang="en-IE" sz="1200" dirty="0"/>
+                        <a:t>Mode</a:t>
+                      </a:r>
+                    </a:p>
+                  </a:txBody>
+                  <a:tcPr/>
+                </a:tc>
+                <a:tc>
+                  <a:txBody>
+                    <a:bodyPr/>
+                    <a:lstStyle/>
+                    <a:p>
+                      <a:r>
+                        <a:rPr lang="en-IE" sz="1200" dirty="0"/>
+                        <a:t>Mode Freq</a:t>
+                      </a:r>
+                    </a:p>
+                  </a:txBody>
+                  <a:tcPr/>
+                </a:tc>
+                <a:tc>
+                  <a:txBody>
+                    <a:bodyPr/>
+                    <a:lstStyle/>
+                    <a:p>
+                      <a:r>
+                        <a:rPr lang="en-IE" sz="1200" dirty="0"/>
+                        <a:t>Mode %</a:t>
+                      </a:r>
+                    </a:p>
+                  </a:txBody>
+                  <a:tcPr/>
+                </a:tc>
+                <a:tc>
+                  <a:txBody>
+                    <a:bodyPr/>
+                    <a:lstStyle/>
+                    <a:p>
+                      <a:r>
+                        <a:rPr lang="en-IE" sz="1200" dirty="0"/>
+                        <a:t>2</a:t>
+                      </a:r>
+                      <a:r>
+                        <a:rPr lang="en-IE" sz="1200" baseline="30000" dirty="0"/>
+                        <a:t>nd</a:t>
+                      </a:r>
+                      <a:r>
+                        <a:rPr lang="en-IE" sz="1200" dirty="0"/>
+                        <a:t> Mode </a:t>
+                      </a:r>
+                    </a:p>
+                  </a:txBody>
+                  <a:tcPr/>
+                </a:tc>
+                <a:tc>
+                  <a:txBody>
+                    <a:bodyPr/>
+                    <a:lstStyle/>
+                    <a:p>
+                      <a:pPr marL="0" marR="0" lvl="0" indent="0" algn="l" defTabSz="914400" rtl="0" eaLnBrk="1" fontAlgn="auto" latinLnBrk="0" hangingPunct="1">
+                        <a:lnSpc>
+                          <a:spcPct val="100000"/>
+                        </a:lnSpc>
+                        <a:spcBef>
+                          <a:spcPts val="0"/>
+                        </a:spcBef>
+                        <a:spcAft>
+                          <a:spcPts val="0"/>
+                        </a:spcAft>
+                        <a:buClr>
+                          <a:srgbClr val="000000"/>
+                        </a:buClr>
+                        <a:buSzTx/>
+                        <a:buFont typeface="Arial"/>
+                        <a:buNone/>
+                        <a:tabLst/>
+                        <a:defRPr/>
+                      </a:pPr>
+                      <a:r>
+                        <a:rPr lang="en-IE" sz="1200" dirty="0"/>
+                        <a:t>2</a:t>
+                      </a:r>
+                      <a:r>
+                        <a:rPr lang="en-IE" sz="1200" baseline="30000" dirty="0"/>
+                        <a:t>nd</a:t>
+                      </a:r>
+                      <a:r>
+                        <a:rPr lang="en-IE" sz="1200" dirty="0"/>
+                        <a:t> Mode Freq</a:t>
+                      </a:r>
+                    </a:p>
+                  </a:txBody>
+                  <a:tcPr/>
+                </a:tc>
+                <a:tc>
+                  <a:txBody>
+                    <a:bodyPr/>
+                    <a:lstStyle/>
+                    <a:p>
+                      <a:r>
+                        <a:rPr lang="en-IE" sz="1200" dirty="0"/>
+                        <a:t>2</a:t>
+                      </a:r>
+                      <a:r>
+                        <a:rPr lang="en-IE" sz="1200" baseline="30000" dirty="0"/>
+                        <a:t>nd</a:t>
+                      </a:r>
+                      <a:r>
+                        <a:rPr lang="en-IE" sz="1200" dirty="0"/>
+                        <a:t> Mode %</a:t>
+                      </a:r>
+                    </a:p>
+                  </a:txBody>
+                  <a:tcPr/>
+                </a:tc>
+                <a:tc>
+                  <a:txBody>
+                    <a:bodyPr/>
+                    <a:lstStyle/>
+                    <a:p>
+                      <a:endParaRPr lang="en-IE" sz="1200" dirty="0"/>
+                    </a:p>
+                  </a:txBody>
+                  <a:tcPr/>
+                </a:tc>
+                <a:extLst>
+                  <a:ext uri="{0D108BD9-81ED-4DB2-BD59-A6C34878D82A}">
+                    <a16:rowId xmlns:a16="http://schemas.microsoft.com/office/drawing/2014/main" val="2952155696"/>
+                  </a:ext>
+                </a:extLst>
+              </a:tr>
+              <a:tr h="772931">
+                <a:tc>
+                  <a:txBody>
+                    <a:bodyPr/>
+                    <a:lstStyle/>
+                    <a:p>
+                      <a:r>
+                        <a:rPr lang="en-IE" sz="1200" dirty="0"/>
+                        <a:t>Title </a:t>
+                      </a:r>
+                    </a:p>
+                  </a:txBody>
+                  <a:tcPr/>
+                </a:tc>
+                <a:tc>
+                  <a:txBody>
+                    <a:bodyPr/>
+                    <a:lstStyle/>
+                    <a:p>
+                      <a:endParaRPr lang="en-IE" dirty="0"/>
+                    </a:p>
+                  </a:txBody>
+                  <a:tcPr/>
+                </a:tc>
+                <a:tc>
+                  <a:txBody>
+                    <a:bodyPr/>
+                    <a:lstStyle/>
+                    <a:p>
+                      <a:endParaRPr lang="en-IE"/>
+                    </a:p>
+                  </a:txBody>
+                  <a:tcPr/>
+                </a:tc>
+                <a:tc>
+                  <a:txBody>
+                    <a:bodyPr/>
+                    <a:lstStyle/>
+                    <a:p>
+                      <a:endParaRPr lang="en-IE"/>
+                    </a:p>
+                  </a:txBody>
+                  <a:tcPr/>
+                </a:tc>
+                <a:tc>
+                  <a:txBody>
+                    <a:bodyPr/>
+                    <a:lstStyle/>
+                    <a:p>
+                      <a:endParaRPr lang="en-IE"/>
+                    </a:p>
+                  </a:txBody>
+                  <a:tcPr/>
+                </a:tc>
+                <a:tc>
+                  <a:txBody>
+                    <a:bodyPr/>
+                    <a:lstStyle/>
+                    <a:p>
+                      <a:endParaRPr lang="en-IE" dirty="0"/>
+                    </a:p>
+                  </a:txBody>
+                  <a:tcPr/>
+                </a:tc>
+                <a:tc>
+                  <a:txBody>
+                    <a:bodyPr/>
+                    <a:lstStyle/>
+                    <a:p>
+                      <a:endParaRPr lang="en-IE"/>
+                    </a:p>
+                  </a:txBody>
+                  <a:tcPr/>
+                </a:tc>
+                <a:tc>
+                  <a:txBody>
+                    <a:bodyPr/>
+                    <a:lstStyle/>
+                    <a:p>
+                      <a:endParaRPr lang="en-IE"/>
+                    </a:p>
+                  </a:txBody>
+                  <a:tcPr/>
+                </a:tc>
+                <a:tc>
+                  <a:txBody>
+                    <a:bodyPr/>
+                    <a:lstStyle/>
+                    <a:p>
+                      <a:endParaRPr lang="en-IE"/>
+                    </a:p>
+                  </a:txBody>
+                  <a:tcPr/>
+                </a:tc>
+                <a:tc>
+                  <a:txBody>
+                    <a:bodyPr/>
+                    <a:lstStyle/>
+                    <a:p>
+                      <a:endParaRPr lang="en-IE" dirty="0"/>
+                    </a:p>
+                  </a:txBody>
+                  <a:tcPr/>
+                </a:tc>
+                <a:tc>
+                  <a:txBody>
+                    <a:bodyPr/>
+                    <a:lstStyle/>
+                    <a:p>
+                      <a:endParaRPr lang="en-IE"/>
+                    </a:p>
+                  </a:txBody>
+                  <a:tcPr/>
+                </a:tc>
+                <a:extLst>
+                  <a:ext uri="{0D108BD9-81ED-4DB2-BD59-A6C34878D82A}">
+                    <a16:rowId xmlns:a16="http://schemas.microsoft.com/office/drawing/2014/main" val="4276670550"/>
+                  </a:ext>
+                </a:extLst>
+              </a:tr>
+              <a:tr h="772931">
+                <a:tc>
+                  <a:txBody>
+                    <a:bodyPr/>
+                    <a:lstStyle/>
+                    <a:p>
+                      <a:r>
+                        <a:rPr lang="en-IE" sz="1200" dirty="0"/>
+                        <a:t>Year </a:t>
+                      </a:r>
+                    </a:p>
+                  </a:txBody>
+                  <a:tcPr/>
+                </a:tc>
+                <a:tc>
+                  <a:txBody>
+                    <a:bodyPr/>
+                    <a:lstStyle/>
+                    <a:p>
+                      <a:endParaRPr lang="en-IE"/>
+                    </a:p>
+                  </a:txBody>
+                  <a:tcPr/>
+                </a:tc>
+                <a:tc>
+                  <a:txBody>
+                    <a:bodyPr/>
+                    <a:lstStyle/>
+                    <a:p>
+                      <a:endParaRPr lang="en-IE"/>
+                    </a:p>
+                  </a:txBody>
+                  <a:tcPr/>
+                </a:tc>
+                <a:tc>
+                  <a:txBody>
+                    <a:bodyPr/>
+                    <a:lstStyle/>
+                    <a:p>
+                      <a:endParaRPr lang="en-IE" dirty="0"/>
+                    </a:p>
+                  </a:txBody>
+                  <a:tcPr/>
+                </a:tc>
+                <a:tc>
+                  <a:txBody>
+                    <a:bodyPr/>
+                    <a:lstStyle/>
+                    <a:p>
+                      <a:endParaRPr lang="en-IE"/>
+                    </a:p>
+                  </a:txBody>
+                  <a:tcPr/>
+                </a:tc>
+                <a:tc>
+                  <a:txBody>
+                    <a:bodyPr/>
+                    <a:lstStyle/>
+                    <a:p>
+                      <a:endParaRPr lang="en-IE"/>
+                    </a:p>
+                  </a:txBody>
+                  <a:tcPr/>
+                </a:tc>
+                <a:tc>
+                  <a:txBody>
+                    <a:bodyPr/>
+                    <a:lstStyle/>
+                    <a:p>
+                      <a:endParaRPr lang="en-IE"/>
+                    </a:p>
+                  </a:txBody>
+                  <a:tcPr/>
+                </a:tc>
+                <a:tc>
+                  <a:txBody>
+                    <a:bodyPr/>
+                    <a:lstStyle/>
+                    <a:p>
+                      <a:endParaRPr lang="en-IE"/>
+                    </a:p>
+                  </a:txBody>
+                  <a:tcPr/>
+                </a:tc>
+                <a:tc>
+                  <a:txBody>
+                    <a:bodyPr/>
+                    <a:lstStyle/>
+                    <a:p>
+                      <a:endParaRPr lang="en-IE"/>
+                    </a:p>
+                  </a:txBody>
+                  <a:tcPr/>
+                </a:tc>
+                <a:tc>
+                  <a:txBody>
+                    <a:bodyPr/>
+                    <a:lstStyle/>
+                    <a:p>
+                      <a:endParaRPr lang="en-IE"/>
+                    </a:p>
+                  </a:txBody>
+                  <a:tcPr/>
+                </a:tc>
+                <a:tc>
+                  <a:txBody>
+                    <a:bodyPr/>
+                    <a:lstStyle/>
+                    <a:p>
+                      <a:endParaRPr lang="en-IE"/>
+                    </a:p>
+                  </a:txBody>
+                  <a:tcPr/>
+                </a:tc>
+                <a:extLst>
+                  <a:ext uri="{0D108BD9-81ED-4DB2-BD59-A6C34878D82A}">
+                    <a16:rowId xmlns:a16="http://schemas.microsoft.com/office/drawing/2014/main" val="1893299196"/>
+                  </a:ext>
+                </a:extLst>
+              </a:tr>
+              <a:tr h="772931">
+                <a:tc>
+                  <a:txBody>
+                    <a:bodyPr/>
+                    <a:lstStyle/>
+                    <a:p>
+                      <a:r>
+                        <a:rPr lang="en-IE" sz="1200" dirty="0"/>
+                        <a:t>Certificate </a:t>
+                      </a:r>
+                    </a:p>
+                  </a:txBody>
+                  <a:tcPr/>
+                </a:tc>
+                <a:tc>
+                  <a:txBody>
+                    <a:bodyPr/>
+                    <a:lstStyle/>
+                    <a:p>
+                      <a:endParaRPr lang="en-IE" dirty="0"/>
+                    </a:p>
+                  </a:txBody>
+                  <a:tcPr/>
+                </a:tc>
+                <a:tc>
+                  <a:txBody>
+                    <a:bodyPr/>
+                    <a:lstStyle/>
+                    <a:p>
+                      <a:endParaRPr lang="en-IE"/>
+                    </a:p>
+                  </a:txBody>
+                  <a:tcPr/>
+                </a:tc>
+                <a:tc>
+                  <a:txBody>
+                    <a:bodyPr/>
+                    <a:lstStyle/>
+                    <a:p>
+                      <a:endParaRPr lang="en-IE"/>
+                    </a:p>
+                  </a:txBody>
+                  <a:tcPr/>
+                </a:tc>
+                <a:tc>
+                  <a:txBody>
+                    <a:bodyPr/>
+                    <a:lstStyle/>
+                    <a:p>
+                      <a:endParaRPr lang="en-IE"/>
+                    </a:p>
+                  </a:txBody>
+                  <a:tcPr/>
+                </a:tc>
+                <a:tc>
+                  <a:txBody>
+                    <a:bodyPr/>
+                    <a:lstStyle/>
+                    <a:p>
+                      <a:endParaRPr lang="en-IE"/>
+                    </a:p>
+                  </a:txBody>
+                  <a:tcPr/>
+                </a:tc>
+                <a:tc>
+                  <a:txBody>
+                    <a:bodyPr/>
+                    <a:lstStyle/>
+                    <a:p>
+                      <a:endParaRPr lang="en-IE"/>
+                    </a:p>
+                  </a:txBody>
+                  <a:tcPr/>
+                </a:tc>
+                <a:tc>
+                  <a:txBody>
+                    <a:bodyPr/>
+                    <a:lstStyle/>
+                    <a:p>
+                      <a:endParaRPr lang="en-IE"/>
+                    </a:p>
+                  </a:txBody>
+                  <a:tcPr/>
+                </a:tc>
+                <a:tc>
+                  <a:txBody>
+                    <a:bodyPr/>
+                    <a:lstStyle/>
+                    <a:p>
+                      <a:endParaRPr lang="en-IE"/>
+                    </a:p>
+                  </a:txBody>
+                  <a:tcPr/>
+                </a:tc>
+                <a:tc>
+                  <a:txBody>
+                    <a:bodyPr/>
+                    <a:lstStyle/>
+                    <a:p>
+                      <a:endParaRPr lang="en-IE"/>
+                    </a:p>
+                  </a:txBody>
+                  <a:tcPr/>
+                </a:tc>
+                <a:tc>
+                  <a:txBody>
+                    <a:bodyPr/>
+                    <a:lstStyle/>
+                    <a:p>
+                      <a:endParaRPr lang="en-IE" dirty="0"/>
+                    </a:p>
+                  </a:txBody>
+                  <a:tcPr/>
+                </a:tc>
+                <a:extLst>
+                  <a:ext uri="{0D108BD9-81ED-4DB2-BD59-A6C34878D82A}">
+                    <a16:rowId xmlns:a16="http://schemas.microsoft.com/office/drawing/2014/main" val="3659900118"/>
+                  </a:ext>
+                </a:extLst>
+              </a:tr>
+              <a:tr h="772931">
+                <a:tc>
+                  <a:txBody>
+                    <a:bodyPr/>
+                    <a:lstStyle/>
+                    <a:p>
+                      <a:r>
+                        <a:rPr lang="en-IE" sz="1200" dirty="0"/>
+                        <a:t>Genre </a:t>
+                      </a:r>
+                    </a:p>
+                  </a:txBody>
+                  <a:tcPr/>
+                </a:tc>
+                <a:tc>
+                  <a:txBody>
+                    <a:bodyPr/>
+                    <a:lstStyle/>
+                    <a:p>
+                      <a:endParaRPr lang="en-IE"/>
+                    </a:p>
+                  </a:txBody>
+                  <a:tcPr/>
+                </a:tc>
+                <a:tc>
+                  <a:txBody>
+                    <a:bodyPr/>
+                    <a:lstStyle/>
+                    <a:p>
+                      <a:endParaRPr lang="en-IE"/>
+                    </a:p>
+                  </a:txBody>
+                  <a:tcPr/>
+                </a:tc>
+                <a:tc>
+                  <a:txBody>
+                    <a:bodyPr/>
+                    <a:lstStyle/>
+                    <a:p>
+                      <a:endParaRPr lang="en-IE"/>
+                    </a:p>
+                  </a:txBody>
+                  <a:tcPr/>
+                </a:tc>
+                <a:tc>
+                  <a:txBody>
+                    <a:bodyPr/>
+                    <a:lstStyle/>
+                    <a:p>
+                      <a:endParaRPr lang="en-IE"/>
+                    </a:p>
+                  </a:txBody>
+                  <a:tcPr/>
+                </a:tc>
+                <a:tc>
+                  <a:txBody>
+                    <a:bodyPr/>
+                    <a:lstStyle/>
+                    <a:p>
+                      <a:endParaRPr lang="en-IE"/>
+                    </a:p>
+                  </a:txBody>
+                  <a:tcPr/>
+                </a:tc>
+                <a:tc>
+                  <a:txBody>
+                    <a:bodyPr/>
+                    <a:lstStyle/>
+                    <a:p>
+                      <a:endParaRPr lang="en-IE"/>
+                    </a:p>
+                  </a:txBody>
+                  <a:tcPr/>
+                </a:tc>
+                <a:tc>
+                  <a:txBody>
+                    <a:bodyPr/>
+                    <a:lstStyle/>
+                    <a:p>
+                      <a:endParaRPr lang="en-IE"/>
+                    </a:p>
+                  </a:txBody>
+                  <a:tcPr/>
+                </a:tc>
+                <a:tc>
+                  <a:txBody>
+                    <a:bodyPr/>
+                    <a:lstStyle/>
+                    <a:p>
+                      <a:endParaRPr lang="en-IE"/>
+                    </a:p>
+                  </a:txBody>
+                  <a:tcPr/>
+                </a:tc>
+                <a:tc>
+                  <a:txBody>
+                    <a:bodyPr/>
+                    <a:lstStyle/>
+                    <a:p>
+                      <a:endParaRPr lang="en-IE"/>
+                    </a:p>
+                  </a:txBody>
+                  <a:tcPr/>
+                </a:tc>
+                <a:tc>
+                  <a:txBody>
+                    <a:bodyPr/>
+                    <a:lstStyle/>
+                    <a:p>
+                      <a:endParaRPr lang="en-IE" dirty="0"/>
+                    </a:p>
+                  </a:txBody>
+                  <a:tcPr/>
+                </a:tc>
+                <a:extLst>
+                  <a:ext uri="{0D108BD9-81ED-4DB2-BD59-A6C34878D82A}">
+                    <a16:rowId xmlns:a16="http://schemas.microsoft.com/office/drawing/2014/main" val="438441145"/>
+                  </a:ext>
+                </a:extLst>
+              </a:tr>
+            </a:tbl>
+          </a:graphicData>
+        </a:graphic>
+      </p:graphicFrame>
+    </p:spTree>
+    <p:extLst>
+      <p:ext uri="{BB962C8B-B14F-4D97-AF65-F5344CB8AC3E}">
+        <p14:creationId xmlns:p14="http://schemas.microsoft.com/office/powerpoint/2010/main" val="2263138154"/>
+      </p:ext>
+    </p:extLst>
+  </p:cSld>
+  <p:clrMapOvr>
+    <a:masterClrMapping/>
+  </p:clrMapOvr>
+</p:sld>
+</file>
+
+<file path=ppt/slides/slide15.xml><?xml version="1.0" encoding="utf-8"?>
+<p:sld xmlns:a="http://schemas.openxmlformats.org/drawingml/2006/main" xmlns:r="http://schemas.openxmlformats.org/officeDocument/2006/relationships" xmlns:p="http://schemas.openxmlformats.org/presentationml/2006/main">
+  <p:cSld>
+    <p:spTree>
+      <p:nvGrpSpPr>
         <p:cNvPr id="1" name="Shape 112"/>
         <p:cNvGrpSpPr/>
         <p:nvPr/>
@@ -8044,7 +9821,7 @@
 </p:sld>
 </file>
 
-<file path=ppt/slides/slide14.xml><?xml version="1.0" encoding="utf-8"?>
+<file path=ppt/slides/slide16.xml><?xml version="1.0" encoding="utf-8"?>
 <p:sld xmlns:a="http://schemas.openxmlformats.org/drawingml/2006/main" xmlns:r="http://schemas.openxmlformats.org/officeDocument/2006/relationships" xmlns:p="http://schemas.openxmlformats.org/presentationml/2006/main">
   <p:cSld>
     <p:spTree>
@@ -8111,7 +9888,7 @@
 </p:sld>
 </file>
 
-<file path=ppt/slides/slide15.xml><?xml version="1.0" encoding="utf-8"?>
+<file path=ppt/slides/slide17.xml><?xml version="1.0" encoding="utf-8"?>
 <p:sld xmlns:a="http://schemas.openxmlformats.org/drawingml/2006/main" xmlns:r="http://schemas.openxmlformats.org/officeDocument/2006/relationships" xmlns:p="http://schemas.openxmlformats.org/presentationml/2006/main">
   <p:cSld>
     <p:spTree>
@@ -8236,7 +10013,7 @@
 </p:sld>
 </file>
 
-<file path=ppt/slides/slide16.xml><?xml version="1.0" encoding="utf-8"?>
+<file path=ppt/slides/slide18.xml><?xml version="1.0" encoding="utf-8"?>
 <p:sld xmlns:a="http://schemas.openxmlformats.org/drawingml/2006/main" xmlns:r="http://schemas.openxmlformats.org/officeDocument/2006/relationships" xmlns:p="http://schemas.openxmlformats.org/presentationml/2006/main">
   <p:cSld>
     <p:spTree>
@@ -8366,7 +10143,7 @@
 </p:sld>
 </file>
 
-<file path=ppt/slides/slide17.xml><?xml version="1.0" encoding="utf-8"?>
+<file path=ppt/slides/slide19.xml><?xml version="1.0" encoding="utf-8"?>
 <p:sld xmlns:a="http://schemas.openxmlformats.org/drawingml/2006/main" xmlns:r="http://schemas.openxmlformats.org/officeDocument/2006/relationships" xmlns:p="http://schemas.openxmlformats.org/presentationml/2006/main">
   <p:cSld>
     <p:spTree>
@@ -8489,183 +10266,6 @@
         <p14:creationId xmlns:p14="http://schemas.microsoft.com/office/powerpoint/2010/main" val="1953296343"/>
       </p:ext>
     </p:extLst>
-  </p:cSld>
-  <p:clrMapOvr>
-    <a:masterClrMapping/>
-  </p:clrMapOvr>
-</p:sld>
-</file>
-
-<file path=ppt/slides/slide18.xml><?xml version="1.0" encoding="utf-8"?>
-<p:sld xmlns:a="http://schemas.openxmlformats.org/drawingml/2006/main" xmlns:r="http://schemas.openxmlformats.org/officeDocument/2006/relationships" xmlns:p="http://schemas.openxmlformats.org/presentationml/2006/main">
-  <p:cSld>
-    <p:spTree>
-      <p:nvGrpSpPr>
-        <p:cNvPr id="1" name="Shape 178"/>
-        <p:cNvGrpSpPr/>
-        <p:nvPr/>
-      </p:nvGrpSpPr>
-      <p:grpSpPr>
-        <a:xfrm>
-          <a:off x="0" y="0"/>
-          <a:ext cx="0" cy="0"/>
-          <a:chOff x="0" y="0"/>
-          <a:chExt cx="0" cy="0"/>
-        </a:xfrm>
-      </p:grpSpPr>
-      <p:sp>
-        <p:nvSpPr>
-          <p:cNvPr id="179" name="Google Shape;179;p34"/>
-          <p:cNvSpPr txBox="1">
-            <a:spLocks noGrp="1"/>
-          </p:cNvSpPr>
-          <p:nvPr>
-            <p:ph type="title"/>
-          </p:nvPr>
-        </p:nvSpPr>
-        <p:spPr>
-          <a:xfrm>
-            <a:off x="311700" y="2150850"/>
-            <a:ext cx="8520600" cy="841800"/>
-          </a:xfrm>
-          <a:prstGeom prst="rect">
-            <a:avLst/>
-          </a:prstGeom>
-        </p:spPr>
-        <p:txBody>
-          <a:bodyPr spcFirstLastPara="1" wrap="square" lIns="91425" tIns="91425" rIns="91425" bIns="91425" anchor="ctr" anchorCtr="0">
-            <a:normAutofit/>
-          </a:bodyPr>
-          <a:lstStyle/>
-          <a:p>
-            <a:pPr marL="0" lvl="0" indent="0" algn="ctr" rtl="0">
-              <a:spcBef>
-                <a:spcPts val="0"/>
-              </a:spcBef>
-              <a:spcAft>
-                <a:spcPts val="0"/>
-              </a:spcAft>
-              <a:buNone/>
-            </a:pPr>
-            <a:r>
-              <a:rPr lang="en-GB" dirty="0"/>
-              <a:t>4. Conclusions</a:t>
-            </a:r>
-            <a:endParaRPr dirty="0"/>
-          </a:p>
-        </p:txBody>
-      </p:sp>
-    </p:spTree>
-  </p:cSld>
-  <p:clrMapOvr>
-    <a:masterClrMapping/>
-  </p:clrMapOvr>
-</p:sld>
-</file>
-
-<file path=ppt/slides/slide19.xml><?xml version="1.0" encoding="utf-8"?>
-<p:sld xmlns:a="http://schemas.openxmlformats.org/drawingml/2006/main" xmlns:r="http://schemas.openxmlformats.org/officeDocument/2006/relationships" xmlns:p="http://schemas.openxmlformats.org/presentationml/2006/main">
-  <p:cSld>
-    <p:spTree>
-      <p:nvGrpSpPr>
-        <p:cNvPr id="1" name="Shape 183"/>
-        <p:cNvGrpSpPr/>
-        <p:nvPr/>
-      </p:nvGrpSpPr>
-      <p:grpSpPr>
-        <a:xfrm>
-          <a:off x="0" y="0"/>
-          <a:ext cx="0" cy="0"/>
-          <a:chOff x="0" y="0"/>
-          <a:chExt cx="0" cy="0"/>
-        </a:xfrm>
-      </p:grpSpPr>
-      <p:sp>
-        <p:nvSpPr>
-          <p:cNvPr id="184" name="Google Shape;184;p35"/>
-          <p:cNvSpPr txBox="1">
-            <a:spLocks noGrp="1"/>
-          </p:cNvSpPr>
-          <p:nvPr>
-            <p:ph type="title"/>
-          </p:nvPr>
-        </p:nvSpPr>
-        <p:spPr>
-          <a:xfrm>
-            <a:off x="311700" y="445025"/>
-            <a:ext cx="8520600" cy="572700"/>
-          </a:xfrm>
-          <a:prstGeom prst="rect">
-            <a:avLst/>
-          </a:prstGeom>
-        </p:spPr>
-        <p:txBody>
-          <a:bodyPr spcFirstLastPara="1" wrap="square" lIns="91425" tIns="91425" rIns="91425" bIns="91425" anchor="t" anchorCtr="0">
-            <a:normAutofit fontScale="90000"/>
-          </a:bodyPr>
-          <a:lstStyle/>
-          <a:p>
-            <a:pPr marL="0" lvl="0" indent="0" algn="l" rtl="0">
-              <a:spcBef>
-                <a:spcPts val="0"/>
-              </a:spcBef>
-              <a:spcAft>
-                <a:spcPts val="0"/>
-              </a:spcAft>
-              <a:buClr>
-                <a:schemeClr val="dk1"/>
-              </a:buClr>
-              <a:buSzPct val="39285"/>
-              <a:buFont typeface="Arial"/>
-              <a:buNone/>
-            </a:pPr>
-            <a:r>
-              <a:rPr lang="en-GB"/>
-              <a:t>Conclusions</a:t>
-            </a:r>
-            <a:endParaRPr/>
-          </a:p>
-        </p:txBody>
-      </p:sp>
-      <p:sp>
-        <p:nvSpPr>
-          <p:cNvPr id="185" name="Google Shape;185;p35"/>
-          <p:cNvSpPr txBox="1">
-            <a:spLocks noGrp="1"/>
-          </p:cNvSpPr>
-          <p:nvPr>
-            <p:ph type="body" idx="1"/>
-          </p:nvPr>
-        </p:nvSpPr>
-        <p:spPr>
-          <a:xfrm>
-            <a:off x="311700" y="1152475"/>
-            <a:ext cx="8520600" cy="3416400"/>
-          </a:xfrm>
-          <a:prstGeom prst="rect">
-            <a:avLst/>
-          </a:prstGeom>
-        </p:spPr>
-        <p:txBody>
-          <a:bodyPr spcFirstLastPara="1" wrap="square" lIns="91425" tIns="91425" rIns="91425" bIns="91425" anchor="t" anchorCtr="0">
-            <a:normAutofit/>
-          </a:bodyPr>
-          <a:lstStyle/>
-          <a:p>
-            <a:pPr marL="0" lvl="0" indent="0" algn="l" rtl="0">
-              <a:spcBef>
-                <a:spcPts val="0"/>
-              </a:spcBef>
-              <a:spcAft>
-                <a:spcPts val="1200"/>
-              </a:spcAft>
-              <a:buNone/>
-            </a:pPr>
-            <a:endParaRPr/>
-          </a:p>
-        </p:txBody>
-      </p:sp>
-    </p:spTree>
   </p:cSld>
   <p:clrMapOvr>
     <a:masterClrMapping/>
@@ -8746,6 +10346,183 @@
   <p:cSld>
     <p:spTree>
       <p:nvGrpSpPr>
+        <p:cNvPr id="1" name="Shape 178"/>
+        <p:cNvGrpSpPr/>
+        <p:nvPr/>
+      </p:nvGrpSpPr>
+      <p:grpSpPr>
+        <a:xfrm>
+          <a:off x="0" y="0"/>
+          <a:ext cx="0" cy="0"/>
+          <a:chOff x="0" y="0"/>
+          <a:chExt cx="0" cy="0"/>
+        </a:xfrm>
+      </p:grpSpPr>
+      <p:sp>
+        <p:nvSpPr>
+          <p:cNvPr id="179" name="Google Shape;179;p34"/>
+          <p:cNvSpPr txBox="1">
+            <a:spLocks noGrp="1"/>
+          </p:cNvSpPr>
+          <p:nvPr>
+            <p:ph type="title"/>
+          </p:nvPr>
+        </p:nvSpPr>
+        <p:spPr>
+          <a:xfrm>
+            <a:off x="311700" y="2150850"/>
+            <a:ext cx="8520600" cy="841800"/>
+          </a:xfrm>
+          <a:prstGeom prst="rect">
+            <a:avLst/>
+          </a:prstGeom>
+        </p:spPr>
+        <p:txBody>
+          <a:bodyPr spcFirstLastPara="1" wrap="square" lIns="91425" tIns="91425" rIns="91425" bIns="91425" anchor="ctr" anchorCtr="0">
+            <a:normAutofit/>
+          </a:bodyPr>
+          <a:lstStyle/>
+          <a:p>
+            <a:pPr marL="0" lvl="0" indent="0" algn="ctr" rtl="0">
+              <a:spcBef>
+                <a:spcPts val="0"/>
+              </a:spcBef>
+              <a:spcAft>
+                <a:spcPts val="0"/>
+              </a:spcAft>
+              <a:buNone/>
+            </a:pPr>
+            <a:r>
+              <a:rPr lang="en-GB" dirty="0"/>
+              <a:t>4. Conclusions</a:t>
+            </a:r>
+            <a:endParaRPr dirty="0"/>
+          </a:p>
+        </p:txBody>
+      </p:sp>
+    </p:spTree>
+  </p:cSld>
+  <p:clrMapOvr>
+    <a:masterClrMapping/>
+  </p:clrMapOvr>
+</p:sld>
+</file>
+
+<file path=ppt/slides/slide21.xml><?xml version="1.0" encoding="utf-8"?>
+<p:sld xmlns:a="http://schemas.openxmlformats.org/drawingml/2006/main" xmlns:r="http://schemas.openxmlformats.org/officeDocument/2006/relationships" xmlns:p="http://schemas.openxmlformats.org/presentationml/2006/main">
+  <p:cSld>
+    <p:spTree>
+      <p:nvGrpSpPr>
+        <p:cNvPr id="1" name="Shape 183"/>
+        <p:cNvGrpSpPr/>
+        <p:nvPr/>
+      </p:nvGrpSpPr>
+      <p:grpSpPr>
+        <a:xfrm>
+          <a:off x="0" y="0"/>
+          <a:ext cx="0" cy="0"/>
+          <a:chOff x="0" y="0"/>
+          <a:chExt cx="0" cy="0"/>
+        </a:xfrm>
+      </p:grpSpPr>
+      <p:sp>
+        <p:nvSpPr>
+          <p:cNvPr id="184" name="Google Shape;184;p35"/>
+          <p:cNvSpPr txBox="1">
+            <a:spLocks noGrp="1"/>
+          </p:cNvSpPr>
+          <p:nvPr>
+            <p:ph type="title"/>
+          </p:nvPr>
+        </p:nvSpPr>
+        <p:spPr>
+          <a:xfrm>
+            <a:off x="311700" y="445025"/>
+            <a:ext cx="8520600" cy="572700"/>
+          </a:xfrm>
+          <a:prstGeom prst="rect">
+            <a:avLst/>
+          </a:prstGeom>
+        </p:spPr>
+        <p:txBody>
+          <a:bodyPr spcFirstLastPara="1" wrap="square" lIns="91425" tIns="91425" rIns="91425" bIns="91425" anchor="t" anchorCtr="0">
+            <a:normAutofit fontScale="90000"/>
+          </a:bodyPr>
+          <a:lstStyle/>
+          <a:p>
+            <a:pPr marL="0" lvl="0" indent="0" algn="l" rtl="0">
+              <a:spcBef>
+                <a:spcPts val="0"/>
+              </a:spcBef>
+              <a:spcAft>
+                <a:spcPts val="0"/>
+              </a:spcAft>
+              <a:buClr>
+                <a:schemeClr val="dk1"/>
+              </a:buClr>
+              <a:buSzPct val="39285"/>
+              <a:buFont typeface="Arial"/>
+              <a:buNone/>
+            </a:pPr>
+            <a:r>
+              <a:rPr lang="en-GB"/>
+              <a:t>Conclusions</a:t>
+            </a:r>
+            <a:endParaRPr/>
+          </a:p>
+        </p:txBody>
+      </p:sp>
+      <p:sp>
+        <p:nvSpPr>
+          <p:cNvPr id="185" name="Google Shape;185;p35"/>
+          <p:cNvSpPr txBox="1">
+            <a:spLocks noGrp="1"/>
+          </p:cNvSpPr>
+          <p:nvPr>
+            <p:ph type="body" idx="1"/>
+          </p:nvPr>
+        </p:nvSpPr>
+        <p:spPr>
+          <a:xfrm>
+            <a:off x="311700" y="1152475"/>
+            <a:ext cx="8520600" cy="3416400"/>
+          </a:xfrm>
+          <a:prstGeom prst="rect">
+            <a:avLst/>
+          </a:prstGeom>
+        </p:spPr>
+        <p:txBody>
+          <a:bodyPr spcFirstLastPara="1" wrap="square" lIns="91425" tIns="91425" rIns="91425" bIns="91425" anchor="t" anchorCtr="0">
+            <a:normAutofit/>
+          </a:bodyPr>
+          <a:lstStyle/>
+          <a:p>
+            <a:pPr marL="0" lvl="0" indent="0" algn="l" rtl="0">
+              <a:spcBef>
+                <a:spcPts val="0"/>
+              </a:spcBef>
+              <a:spcAft>
+                <a:spcPts val="1200"/>
+              </a:spcAft>
+              <a:buNone/>
+            </a:pPr>
+            <a:endParaRPr/>
+          </a:p>
+        </p:txBody>
+      </p:sp>
+    </p:spTree>
+  </p:cSld>
+  <p:clrMapOvr>
+    <a:masterClrMapping/>
+  </p:clrMapOvr>
+</p:sld>
+</file>
+
+<file path=ppt/slides/slide22.xml><?xml version="1.0" encoding="utf-8"?>
+<p:sld xmlns:a="http://schemas.openxmlformats.org/drawingml/2006/main" xmlns:r="http://schemas.openxmlformats.org/officeDocument/2006/relationships" xmlns:p="http://schemas.openxmlformats.org/presentationml/2006/main">
+  <p:cSld>
+    <p:spTree>
+      <p:nvGrpSpPr>
         <p:cNvPr id="1" name="Shape 189"/>
         <p:cNvGrpSpPr/>
         <p:nvPr/>
@@ -9266,7 +11043,7 @@
         </p:spPr>
         <p:txBody>
           <a:bodyPr spcFirstLastPara="1" wrap="square" lIns="91425" tIns="91425" rIns="91425" bIns="91425" anchor="t" anchorCtr="0">
-            <a:normAutofit/>
+            <a:normAutofit fontScale="92500" lnSpcReduction="10000"/>
           </a:bodyPr>
           <a:lstStyle>
             <a:defPPr marR="0" lvl="0" algn="l" rtl="0">
@@ -9532,8 +11309,21 @@
                   <a:schemeClr val="tx1"/>
                 </a:solidFill>
               </a:rPr>
-              <a:t>Certificate – age rating </a:t>
+              <a:t>Certificate – age </a:t>
             </a:r>
+            <a:r>
+              <a:rPr lang="en-GB" sz="1500">
+                <a:solidFill>
+                  <a:schemeClr val="tx1"/>
+                </a:solidFill>
+              </a:rPr>
+              <a:t>rating (R, PG-13, PG)</a:t>
+            </a:r>
+            <a:endParaRPr lang="en-GB" sz="1500" dirty="0">
+              <a:solidFill>
+                <a:schemeClr val="tx1"/>
+              </a:solidFill>
+            </a:endParaRPr>
           </a:p>
           <a:p>
             <a:pPr marL="285750" indent="-285750">
@@ -9591,7 +11381,26 @@
                   <a:schemeClr val="tx1"/>
                 </a:solidFill>
               </a:rPr>
-              <a:t>Gross income – worldwide box office revenue </a:t>
+              <a:t>Gross income – worldwide box office revenue</a:t>
+            </a:r>
+          </a:p>
+          <a:p>
+            <a:pPr marL="0" indent="0">
+              <a:lnSpc>
+                <a:spcPct val="114999"/>
+              </a:lnSpc>
+              <a:spcAft>
+                <a:spcPts val="1200"/>
+              </a:spcAft>
+              <a:buNone/>
+            </a:pPr>
+            <a:r>
+              <a:rPr lang="en-GB" sz="1500" dirty="0">
+                <a:solidFill>
+                  <a:schemeClr val="tx1"/>
+                </a:solidFill>
+              </a:rPr>
+              <a:t>      in dollars </a:t>
             </a:r>
           </a:p>
           <a:p>
@@ -11272,7 +13081,7 @@
                     <a:bodyPr/>
                     <a:lstStyle/>
                     <a:p>
-                      <a:endParaRPr lang="en-IE"/>
+                      <a:endParaRPr lang="en-IE" dirty="0"/>
                     </a:p>
                   </a:txBody>
                   <a:tcPr/>

</xml_diff>